<commit_message>
Added updated slide show
</commit_message>
<xml_diff>
--- a/docs/Navy and White Modern Group Project Presentation.pptx
+++ b/docs/Navy and White Modern Group Project Presentation.pptx
@@ -29,32 +29,31 @@
     <p:sldId id="277" r:id="rId23"/>
     <p:sldId id="278" r:id="rId24"/>
     <p:sldId id="279" r:id="rId25"/>
-    <p:sldId id="280" r:id="rId26"/>
-    <p:sldId id="281" r:id="rId27"/>
-    <p:sldId id="283" r:id="rId28"/>
+    <p:sldId id="281" r:id="rId26"/>
+    <p:sldId id="283" r:id="rId27"/>
   </p:sldIdLst>
   <p:sldSz cx="18288000" cy="10287000"/>
   <p:notesSz cx="6858000" cy="9144000"/>
   <p:embeddedFontLst>
     <p:embeddedFont>
       <p:font typeface="Canva Sans" panose="020B0604020202020204" charset="0"/>
+      <p:regular r:id="rId28"/>
+    </p:embeddedFont>
+    <p:embeddedFont>
+      <p:font typeface="Canva Sans Bold" panose="020B0604020202020204" charset="0"/>
       <p:regular r:id="rId29"/>
     </p:embeddedFont>
     <p:embeddedFont>
-      <p:font typeface="Canva Sans Bold" panose="020B0604020202020204" charset="0"/>
+      <p:font typeface="Sarabun" panose="020B0604020202020204" charset="-34"/>
       <p:regular r:id="rId30"/>
     </p:embeddedFont>
     <p:embeddedFont>
-      <p:font typeface="Sarabun" panose="020B0604020202020204" charset="-34"/>
+      <p:font typeface="Sarabun Bold" panose="020B0604020202020204" charset="-34"/>
       <p:regular r:id="rId31"/>
     </p:embeddedFont>
     <p:embeddedFont>
-      <p:font typeface="Sarabun Bold" panose="020B0604020202020204" charset="-34"/>
+      <p:font typeface="Sarabun Italics" panose="020B0604020202020204" charset="-34"/>
       <p:regular r:id="rId32"/>
-    </p:embeddedFont>
-    <p:embeddedFont>
-      <p:font typeface="Sarabun Italics" panose="020B0604020202020204" charset="-34"/>
-      <p:regular r:id="rId33"/>
     </p:embeddedFont>
   </p:embeddedFontLst>
   <p:defaultTextStyle>
@@ -13397,462 +13396,6 @@
           <p:nvPr/>
         </p:nvGrpSpPr>
         <p:grpSpPr>
-          <a:xfrm rot="-2200946">
-            <a:off x="-3415698" y="-1152283"/>
-            <a:ext cx="12019375" cy="12893129"/>
-            <a:chOff x="0" y="0"/>
-            <a:chExt cx="2991969" cy="3209471"/>
-          </a:xfrm>
-        </p:grpSpPr>
-        <p:sp>
-          <p:nvSpPr>
-            <p:cNvPr id="3" name="Freeform 3"/>
-            <p:cNvSpPr/>
-            <p:nvPr/>
-          </p:nvSpPr>
-          <p:spPr>
-            <a:xfrm>
-              <a:off x="0" y="0"/>
-              <a:ext cx="2991969" cy="3209471"/>
-            </a:xfrm>
-            <a:custGeom>
-              <a:avLst/>
-              <a:gdLst/>
-              <a:ahLst/>
-              <a:cxnLst/>
-              <a:rect l="l" t="t" r="r" b="b"/>
-              <a:pathLst>
-                <a:path w="2991969" h="3209471">
-                  <a:moveTo>
-                    <a:pt x="32850" y="0"/>
-                  </a:moveTo>
-                  <a:lnTo>
-                    <a:pt x="2959118" y="0"/>
-                  </a:lnTo>
-                  <a:cubicBezTo>
-                    <a:pt x="2967831" y="0"/>
-                    <a:pt x="2976186" y="3461"/>
-                    <a:pt x="2982347" y="9622"/>
-                  </a:cubicBezTo>
-                  <a:cubicBezTo>
-                    <a:pt x="2988508" y="15782"/>
-                    <a:pt x="2991969" y="24138"/>
-                    <a:pt x="2991969" y="32850"/>
-                  </a:cubicBezTo>
-                  <a:lnTo>
-                    <a:pt x="2991969" y="3176621"/>
-                  </a:lnTo>
-                  <a:cubicBezTo>
-                    <a:pt x="2991969" y="3185333"/>
-                    <a:pt x="2988508" y="3193689"/>
-                    <a:pt x="2982347" y="3199849"/>
-                  </a:cubicBezTo>
-                  <a:cubicBezTo>
-                    <a:pt x="2976186" y="3206010"/>
-                    <a:pt x="2967831" y="3209471"/>
-                    <a:pt x="2959118" y="3209471"/>
-                  </a:cubicBezTo>
-                  <a:lnTo>
-                    <a:pt x="32850" y="3209471"/>
-                  </a:lnTo>
-                  <a:cubicBezTo>
-                    <a:pt x="14708" y="3209471"/>
-                    <a:pt x="0" y="3194764"/>
-                    <a:pt x="0" y="3176621"/>
-                  </a:cubicBezTo>
-                  <a:lnTo>
-                    <a:pt x="0" y="32850"/>
-                  </a:lnTo>
-                  <a:cubicBezTo>
-                    <a:pt x="0" y="24138"/>
-                    <a:pt x="3461" y="15782"/>
-                    <a:pt x="9622" y="9622"/>
-                  </a:cubicBezTo>
-                  <a:cubicBezTo>
-                    <a:pt x="15782" y="3461"/>
-                    <a:pt x="24138" y="0"/>
-                    <a:pt x="32850" y="0"/>
-                  </a:cubicBezTo>
-                  <a:close/>
-                </a:path>
-              </a:pathLst>
-            </a:custGeom>
-            <a:solidFill>
-              <a:srgbClr val="002566">
-                <a:alpha val="13725"/>
-              </a:srgbClr>
-            </a:solidFill>
-          </p:spPr>
-          <p:txBody>
-            <a:bodyPr/>
-            <a:lstStyle/>
-            <a:p>
-              <a:endParaRPr lang="en-ZA"/>
-            </a:p>
-          </p:txBody>
-        </p:sp>
-        <p:sp>
-          <p:nvSpPr>
-            <p:cNvPr id="4" name="TextBox 4"/>
-            <p:cNvSpPr txBox="1"/>
-            <p:nvPr/>
-          </p:nvSpPr>
-          <p:spPr>
-            <a:xfrm>
-              <a:off x="0" y="-28575"/>
-              <a:ext cx="2991969" cy="3238046"/>
-            </a:xfrm>
-            <a:prstGeom prst="rect">
-              <a:avLst/>
-            </a:prstGeom>
-          </p:spPr>
-          <p:txBody>
-            <a:bodyPr lIns="50800" tIns="50800" rIns="50800" bIns="50800" rtlCol="0" anchor="ctr"/>
-            <a:lstStyle/>
-            <a:p>
-              <a:pPr algn="ctr">
-                <a:lnSpc>
-                  <a:spcPts val="2659"/>
-                </a:lnSpc>
-              </a:pPr>
-              <a:endParaRPr/>
-            </a:p>
-          </p:txBody>
-        </p:sp>
-      </p:grpSp>
-      <p:grpSp>
-        <p:nvGrpSpPr>
-          <p:cNvPr id="5" name="Group 5"/>
-          <p:cNvGrpSpPr/>
-          <p:nvPr/>
-        </p:nvGrpSpPr>
-        <p:grpSpPr>
-          <a:xfrm rot="-2200946">
-            <a:off x="-2867185" y="-2631682"/>
-            <a:ext cx="12019375" cy="12893129"/>
-            <a:chOff x="0" y="0"/>
-            <a:chExt cx="2991969" cy="3209471"/>
-          </a:xfrm>
-        </p:grpSpPr>
-        <p:sp>
-          <p:nvSpPr>
-            <p:cNvPr id="6" name="Freeform 6"/>
-            <p:cNvSpPr/>
-            <p:nvPr/>
-          </p:nvSpPr>
-          <p:spPr>
-            <a:xfrm>
-              <a:off x="0" y="0"/>
-              <a:ext cx="2991969" cy="3209471"/>
-            </a:xfrm>
-            <a:custGeom>
-              <a:avLst/>
-              <a:gdLst/>
-              <a:ahLst/>
-              <a:cxnLst/>
-              <a:rect l="l" t="t" r="r" b="b"/>
-              <a:pathLst>
-                <a:path w="2991969" h="3209471">
-                  <a:moveTo>
-                    <a:pt x="32850" y="0"/>
-                  </a:moveTo>
-                  <a:lnTo>
-                    <a:pt x="2959118" y="0"/>
-                  </a:lnTo>
-                  <a:cubicBezTo>
-                    <a:pt x="2967831" y="0"/>
-                    <a:pt x="2976186" y="3461"/>
-                    <a:pt x="2982347" y="9622"/>
-                  </a:cubicBezTo>
-                  <a:cubicBezTo>
-                    <a:pt x="2988508" y="15782"/>
-                    <a:pt x="2991969" y="24138"/>
-                    <a:pt x="2991969" y="32850"/>
-                  </a:cubicBezTo>
-                  <a:lnTo>
-                    <a:pt x="2991969" y="3176621"/>
-                  </a:lnTo>
-                  <a:cubicBezTo>
-                    <a:pt x="2991969" y="3185333"/>
-                    <a:pt x="2988508" y="3193689"/>
-                    <a:pt x="2982347" y="3199849"/>
-                  </a:cubicBezTo>
-                  <a:cubicBezTo>
-                    <a:pt x="2976186" y="3206010"/>
-                    <a:pt x="2967831" y="3209471"/>
-                    <a:pt x="2959118" y="3209471"/>
-                  </a:cubicBezTo>
-                  <a:lnTo>
-                    <a:pt x="32850" y="3209471"/>
-                  </a:lnTo>
-                  <a:cubicBezTo>
-                    <a:pt x="14708" y="3209471"/>
-                    <a:pt x="0" y="3194764"/>
-                    <a:pt x="0" y="3176621"/>
-                  </a:cubicBezTo>
-                  <a:lnTo>
-                    <a:pt x="0" y="32850"/>
-                  </a:lnTo>
-                  <a:cubicBezTo>
-                    <a:pt x="0" y="24138"/>
-                    <a:pt x="3461" y="15782"/>
-                    <a:pt x="9622" y="9622"/>
-                  </a:cubicBezTo>
-                  <a:cubicBezTo>
-                    <a:pt x="15782" y="3461"/>
-                    <a:pt x="24138" y="0"/>
-                    <a:pt x="32850" y="0"/>
-                  </a:cubicBezTo>
-                  <a:close/>
-                </a:path>
-              </a:pathLst>
-            </a:custGeom>
-            <a:solidFill>
-              <a:srgbClr val="002566"/>
-            </a:solidFill>
-          </p:spPr>
-          <p:txBody>
-            <a:bodyPr/>
-            <a:lstStyle/>
-            <a:p>
-              <a:endParaRPr lang="en-ZA"/>
-            </a:p>
-          </p:txBody>
-        </p:sp>
-        <p:sp>
-          <p:nvSpPr>
-            <p:cNvPr id="7" name="TextBox 7"/>
-            <p:cNvSpPr txBox="1"/>
-            <p:nvPr/>
-          </p:nvSpPr>
-          <p:spPr>
-            <a:xfrm>
-              <a:off x="0" y="-28575"/>
-              <a:ext cx="2991969" cy="3238046"/>
-            </a:xfrm>
-            <a:prstGeom prst="rect">
-              <a:avLst/>
-            </a:prstGeom>
-          </p:spPr>
-          <p:txBody>
-            <a:bodyPr lIns="50800" tIns="50800" rIns="50800" bIns="50800" rtlCol="0" anchor="ctr"/>
-            <a:lstStyle/>
-            <a:p>
-              <a:pPr algn="ctr">
-                <a:lnSpc>
-                  <a:spcPts val="2659"/>
-                </a:lnSpc>
-              </a:pPr>
-              <a:endParaRPr/>
-            </a:p>
-          </p:txBody>
-        </p:sp>
-      </p:grpSp>
-      <p:pic>
-        <p:nvPicPr>
-          <p:cNvPr id="8" name="Picture 8"/>
-          <p:cNvPicPr>
-            <a:picLocks noChangeAspect="1"/>
-          </p:cNvPicPr>
-          <p:nvPr/>
-        </p:nvPicPr>
-        <p:blipFill>
-          <a:blip r:embed="rId2"/>
-          <a:stretch>
-            <a:fillRect/>
-          </a:stretch>
-        </p:blipFill>
-        <p:spPr>
-          <a:xfrm>
-            <a:off x="11279111" y="1977966"/>
-            <a:ext cx="6407438" cy="6848850"/>
-          </a:xfrm>
-          <a:prstGeom prst="rect">
-            <a:avLst/>
-          </a:prstGeom>
-        </p:spPr>
-      </p:pic>
-      <p:sp>
-        <p:nvSpPr>
-          <p:cNvPr id="9" name="Freeform 9"/>
-          <p:cNvSpPr/>
-          <p:nvPr/>
-        </p:nvSpPr>
-        <p:spPr>
-          <a:xfrm>
-            <a:off x="614699" y="652053"/>
-            <a:ext cx="828002" cy="2347429"/>
-          </a:xfrm>
-          <a:custGeom>
-            <a:avLst/>
-            <a:gdLst/>
-            <a:ahLst/>
-            <a:cxnLst/>
-            <a:rect l="l" t="t" r="r" b="b"/>
-            <a:pathLst>
-              <a:path w="828002" h="2347429">
-                <a:moveTo>
-                  <a:pt x="0" y="0"/>
-                </a:moveTo>
-                <a:lnTo>
-                  <a:pt x="828002" y="0"/>
-                </a:lnTo>
-                <a:lnTo>
-                  <a:pt x="828002" y="2347429"/>
-                </a:lnTo>
-                <a:lnTo>
-                  <a:pt x="0" y="2347429"/>
-                </a:lnTo>
-                <a:lnTo>
-                  <a:pt x="0" y="0"/>
-                </a:lnTo>
-                <a:close/>
-              </a:path>
-            </a:pathLst>
-          </a:custGeom>
-          <a:blipFill>
-            <a:blip>
-              <a:extLst>
-                <a:ext uri="{96DAC541-7B7A-43D3-8B79-37D633B846F1}">
-                  <asvg:svgBlip xmlns:asvg="http://schemas.microsoft.com/office/drawing/2016/SVG/main" r:embed="rId3"/>
-                </a:ext>
-              </a:extLst>
-            </a:blip>
-            <a:stretch>
-              <a:fillRect/>
-            </a:stretch>
-          </a:blipFill>
-        </p:spPr>
-        <p:txBody>
-          <a:bodyPr/>
-          <a:lstStyle/>
-          <a:p>
-            <a:endParaRPr lang="en-ZA"/>
-          </a:p>
-        </p:txBody>
-      </p:sp>
-      <p:sp>
-        <p:nvSpPr>
-          <p:cNvPr id="10" name="TextBox 10"/>
-          <p:cNvSpPr txBox="1"/>
-          <p:nvPr/>
-        </p:nvSpPr>
-        <p:spPr>
-          <a:xfrm>
-            <a:off x="2185386" y="709203"/>
-            <a:ext cx="6726444" cy="670566"/>
-          </a:xfrm>
-          <a:prstGeom prst="rect">
-            <a:avLst/>
-          </a:prstGeom>
-        </p:spPr>
-        <p:txBody>
-          <a:bodyPr lIns="0" tIns="0" rIns="0" bIns="0" rtlCol="0" anchor="t">
-            <a:spAutoFit/>
-          </a:bodyPr>
-          <a:lstStyle/>
-          <a:p>
-            <a:pPr algn="l">
-              <a:lnSpc>
-                <a:spcPts val="5280"/>
-              </a:lnSpc>
-            </a:pPr>
-            <a:r>
-              <a:rPr lang="en-US" sz="4800" b="1">
-                <a:solidFill>
-                  <a:srgbClr val="FFFFFF"/>
-                </a:solidFill>
-                <a:latin typeface="Sarabun Bold"/>
-                <a:ea typeface="Sarabun Bold"/>
-                <a:cs typeface="Sarabun Bold"/>
-                <a:sym typeface="Sarabun Bold"/>
-              </a:rPr>
-              <a:t>TESTING</a:t>
-            </a:r>
-          </a:p>
-        </p:txBody>
-      </p:sp>
-      <p:sp>
-        <p:nvSpPr>
-          <p:cNvPr id="11" name="TextBox 11"/>
-          <p:cNvSpPr txBox="1"/>
-          <p:nvPr/>
-        </p:nvSpPr>
-        <p:spPr>
-          <a:xfrm>
-            <a:off x="2185386" y="4129178"/>
-            <a:ext cx="5953371" cy="4378331"/>
-          </a:xfrm>
-          <a:prstGeom prst="rect">
-            <a:avLst/>
-          </a:prstGeom>
-        </p:spPr>
-        <p:txBody>
-          <a:bodyPr lIns="0" tIns="0" rIns="0" bIns="0" rtlCol="0" anchor="t">
-            <a:spAutoFit/>
-          </a:bodyPr>
-          <a:lstStyle/>
-          <a:p>
-            <a:pPr algn="l">
-              <a:lnSpc>
-                <a:spcPts val="3850"/>
-              </a:lnSpc>
-            </a:pPr>
-            <a:r>
-              <a:rPr lang="en-US" sz="3500">
-                <a:solidFill>
-                  <a:srgbClr val="FFFFFF"/>
-                </a:solidFill>
-                <a:latin typeface="Sarabun"/>
-                <a:ea typeface="Sarabun"/>
-                <a:cs typeface="Sarabun"/>
-                <a:sym typeface="Sarabun"/>
-              </a:rPr>
-              <a:t>Lorem ipsum dolor sit amet, consectetur adipiscing elit, sed do eiusmod tempor incididunt ut labore et dolore magna aliqua. Ut enim ad minim veniam, quis nostrud exercitation ullamco laboris nisi ut aliquip ex ea commodo consequat.</a:t>
-            </a:r>
-          </a:p>
-        </p:txBody>
-      </p:sp>
-    </p:spTree>
-  </p:cSld>
-  <p:clrMapOvr>
-    <a:masterClrMapping/>
-  </p:clrMapOvr>
-</p:sld>
-</file>
-
-<file path=ppt/slides/slide26.xml><?xml version="1.0" encoding="utf-8"?>
-<p:sld xmlns:a="http://schemas.openxmlformats.org/drawingml/2006/main" xmlns:r="http://schemas.openxmlformats.org/officeDocument/2006/relationships" xmlns:p="http://schemas.openxmlformats.org/presentationml/2006/main">
-  <p:cSld>
-    <p:bg>
-      <p:bgPr>
-        <a:solidFill>
-          <a:srgbClr val="F0F1EC"/>
-        </a:solidFill>
-        <a:effectLst/>
-      </p:bgPr>
-    </p:bg>
-    <p:spTree>
-      <p:nvGrpSpPr>
-        <p:cNvPr id="1" name=""/>
-        <p:cNvGrpSpPr/>
-        <p:nvPr/>
-      </p:nvGrpSpPr>
-      <p:grpSpPr>
-        <a:xfrm>
-          <a:off x="0" y="0"/>
-          <a:ext cx="0" cy="0"/>
-          <a:chOff x="0" y="0"/>
-          <a:chExt cx="0" cy="0"/>
-        </a:xfrm>
-      </p:grpSpPr>
-      <p:grpSp>
-        <p:nvGrpSpPr>
-          <p:cNvPr id="2" name="Group 2"/>
-          <p:cNvGrpSpPr/>
-          <p:nvPr/>
-        </p:nvGrpSpPr>
-        <p:grpSpPr>
           <a:xfrm rot="-1693811">
             <a:off x="8635485" y="-485258"/>
             <a:ext cx="11156868" cy="15883501"/>
@@ -14452,7 +13995,7 @@
 </p:sld>
 </file>
 
-<file path=ppt/slides/slide27.xml><?xml version="1.0" encoding="utf-8"?>
+<file path=ppt/slides/slide26.xml><?xml version="1.0" encoding="utf-8"?>
 <p:sld xmlns:a="http://schemas.openxmlformats.org/drawingml/2006/main" xmlns:r="http://schemas.openxmlformats.org/officeDocument/2006/relationships" xmlns:p="http://schemas.openxmlformats.org/presentationml/2006/main">
   <p:cSld>
     <p:bg>

</xml_diff>